<commit_message>
Update presentation and add .vercel, .env* to .gitignore
</commit_message>
<xml_diff>
--- a/presentation/KeyForge_Presentation.pptx
+++ b/presentation/KeyForge_Presentation.pptx
@@ -321,7 +321,7 @@
           <a:p>
             <a:fld id="{5BCAD085-E8A6-8845-BD4E-CB4CCA059FC4}" type="datetimeFigureOut">
               <a:rPr lang="en-US" smtClean="0"/>
-              <a:t>8/2/2026</a:t>
+              <a:t>8/4/2026</a:t>
             </a:fld>
             <a:endParaRPr lang="en-US"/>
           </a:p>
@@ -489,7 +489,7 @@
           <a:p>
             <a:fld id="{5BCAD085-E8A6-8845-BD4E-CB4CCA059FC4}" type="datetimeFigureOut">
               <a:rPr lang="en-US" smtClean="0"/>
-              <a:t>8/2/2026</a:t>
+              <a:t>8/4/2026</a:t>
             </a:fld>
             <a:endParaRPr lang="en-US"/>
           </a:p>
@@ -667,7 +667,7 @@
           <a:p>
             <a:fld id="{5BCAD085-E8A6-8845-BD4E-CB4CCA059FC4}" type="datetimeFigureOut">
               <a:rPr lang="en-US" smtClean="0"/>
-              <a:t>8/2/2026</a:t>
+              <a:t>8/4/2026</a:t>
             </a:fld>
             <a:endParaRPr lang="en-US"/>
           </a:p>
@@ -835,7 +835,7 @@
           <a:p>
             <a:fld id="{5BCAD085-E8A6-8845-BD4E-CB4CCA059FC4}" type="datetimeFigureOut">
               <a:rPr lang="en-US" smtClean="0"/>
-              <a:t>8/2/2026</a:t>
+              <a:t>8/4/2026</a:t>
             </a:fld>
             <a:endParaRPr lang="en-US"/>
           </a:p>
@@ -1080,7 +1080,7 @@
           <a:p>
             <a:fld id="{5BCAD085-E8A6-8845-BD4E-CB4CCA059FC4}" type="datetimeFigureOut">
               <a:rPr lang="en-US" smtClean="0"/>
-              <a:t>8/2/2026</a:t>
+              <a:t>8/4/2026</a:t>
             </a:fld>
             <a:endParaRPr lang="en-US"/>
           </a:p>
@@ -1365,7 +1365,7 @@
           <a:p>
             <a:fld id="{5BCAD085-E8A6-8845-BD4E-CB4CCA059FC4}" type="datetimeFigureOut">
               <a:rPr lang="en-US" smtClean="0"/>
-              <a:t>8/2/2026</a:t>
+              <a:t>8/4/2026</a:t>
             </a:fld>
             <a:endParaRPr lang="en-US"/>
           </a:p>
@@ -1784,7 +1784,7 @@
           <a:p>
             <a:fld id="{5BCAD085-E8A6-8845-BD4E-CB4CCA059FC4}" type="datetimeFigureOut">
               <a:rPr lang="en-US" smtClean="0"/>
-              <a:t>8/2/2026</a:t>
+              <a:t>8/4/2026</a:t>
             </a:fld>
             <a:endParaRPr lang="en-US"/>
           </a:p>
@@ -1901,7 +1901,7 @@
           <a:p>
             <a:fld id="{5BCAD085-E8A6-8845-BD4E-CB4CCA059FC4}" type="datetimeFigureOut">
               <a:rPr lang="en-US" smtClean="0"/>
-              <a:t>8/2/2026</a:t>
+              <a:t>8/4/2026</a:t>
             </a:fld>
             <a:endParaRPr lang="en-US"/>
           </a:p>
@@ -1996,7 +1996,7 @@
           <a:p>
             <a:fld id="{5BCAD085-E8A6-8845-BD4E-CB4CCA059FC4}" type="datetimeFigureOut">
               <a:rPr lang="en-US" smtClean="0"/>
-              <a:t>8/2/2026</a:t>
+              <a:t>8/4/2026</a:t>
             </a:fld>
             <a:endParaRPr lang="en-US"/>
           </a:p>
@@ -2271,7 +2271,7 @@
           <a:p>
             <a:fld id="{5BCAD085-E8A6-8845-BD4E-CB4CCA059FC4}" type="datetimeFigureOut">
               <a:rPr lang="en-US" smtClean="0"/>
-              <a:t>8/2/2026</a:t>
+              <a:t>8/4/2026</a:t>
             </a:fld>
             <a:endParaRPr lang="en-US"/>
           </a:p>
@@ -2523,7 +2523,7 @@
           <a:p>
             <a:fld id="{5BCAD085-E8A6-8845-BD4E-CB4CCA059FC4}" type="datetimeFigureOut">
               <a:rPr lang="en-US" smtClean="0"/>
-              <a:t>8/2/2026</a:t>
+              <a:t>8/4/2026</a:t>
             </a:fld>
             <a:endParaRPr lang="en-US"/>
           </a:p>
@@ -2734,7 +2734,7 @@
           <a:p>
             <a:fld id="{5BCAD085-E8A6-8845-BD4E-CB4CCA059FC4}" type="datetimeFigureOut">
               <a:rPr lang="en-US" smtClean="0"/>
-              <a:t>8/2/2026</a:t>
+              <a:t>8/4/2026</a:t>
             </a:fld>
             <a:endParaRPr lang="en-US"/>
           </a:p>
@@ -17467,22 +17467,22 @@
         <p:spPr>
           <a:xfrm>
             <a:off x="804672" y="5486400"/>
-            <a:ext cx="10607040" cy="914400"/>
-          </a:xfrm>
-          <a:prstGeom prst="rect">
-            <a:avLst/>
-          </a:prstGeom>
-          <a:noFill/>
-        </p:spPr>
-        <p:txBody>
-          <a:bodyPr wrap="square" anchor="t">
-            <a:spAutoFit/>
-          </a:bodyPr>
-          <a:lstStyle/>
-          <a:p>
-            <a:pPr algn="l"/>
-            <a:r>
-              <a:rPr sz="1300" b="1" i="0">
+            <a:ext cx="10607040" cy="692497"/>
+          </a:xfrm>
+          <a:prstGeom prst="rect">
+            <a:avLst/>
+          </a:prstGeom>
+          <a:noFill/>
+        </p:spPr>
+        <p:txBody>
+          <a:bodyPr wrap="square" anchor="t">
+            <a:spAutoFit/>
+          </a:bodyPr>
+          <a:lstStyle/>
+          <a:p>
+            <a:pPr algn="l"/>
+            <a:r>
+              <a:rPr sz="1300" b="1" i="0" dirty="0">
                 <a:solidFill>
                   <a:srgbClr val="FFFFFF"/>
                 </a:solidFill>
@@ -17491,19 +17491,35 @@
               <a:t>Live demo:  </a:t>
             </a:r>
             <a:r>
-              <a:rPr sz="1300" b="0" i="0">
+              <a:rPr sz="1300" b="0" i="0" dirty="0">
                 <a:solidFill>
                   <a:srgbClr val="3D94FF"/>
                 </a:solidFill>
                 <a:latin typeface="Segoe UI"/>
+                <a:hlinkClick r:id="rId2"/>
               </a:rPr>
               <a:t>https://key-forge-final-project.vercel.app</a:t>
             </a:r>
-          </a:p>
-          <a:p>
-            <a:pPr algn="l"/>
-            <a:r>
-              <a:rPr sz="1300" b="1" i="0">
+            <a:endParaRPr lang="en-US" sz="1300" b="0" i="0" dirty="0">
+              <a:solidFill>
+                <a:srgbClr val="3D94FF"/>
+              </a:solidFill>
+              <a:latin typeface="Segoe UI"/>
+            </a:endParaRPr>
+          </a:p>
+          <a:p>
+            <a:pPr algn="l"/>
+            <a:endParaRPr sz="1300" b="0" i="0" dirty="0">
+              <a:solidFill>
+                <a:srgbClr val="3D94FF"/>
+              </a:solidFill>
+              <a:latin typeface="Segoe UI"/>
+            </a:endParaRPr>
+          </a:p>
+          <a:p>
+            <a:pPr algn="l"/>
+            <a:r>
+              <a:rPr sz="1300" b="1" i="0" dirty="0">
                 <a:solidFill>
                   <a:srgbClr val="FFFFFF"/>
                 </a:solidFill>
@@ -17512,7 +17528,7 @@
               <a:t>Source:  </a:t>
             </a:r>
             <a:r>
-              <a:rPr sz="1300" b="0" i="0">
+              <a:rPr sz="1300" b="0" i="0" dirty="0">
                 <a:solidFill>
                   <a:srgbClr val="3D94FF"/>
                 </a:solidFill>

</xml_diff>